<commit_message>
Reword the Cabinet deck: local-only statement, full portal names, HPC roadmap
Title slide drops the audience line. The slide 3 statement says all models run
locally with no external, closed-source, or proprietary tool. IESCMS is spelled
out as the Integrated Excise Supply Chain Management System. The revenue,
sales-volume, and enforcement figures are attributed to the Rajkosh and
Koshwani portal data. The roadmap names a high-performance computing node with
high-end GPU servers. SLIDE-TRANSCRIPT.md carries the same changes.

Co-Authored-By: Claude Sonnet 5.5 <noreply@anthropic.com>
</commit_message>
<xml_diff>
--- a/deck/UP-Excise-Ask-the-Data-Demo.pptx
+++ b/deck/UP-Excise-Ask-the-Data-Demo.pptx
@@ -4837,7 +4837,7 @@
                 </a:solidFill>
                 <a:latin typeface="Calibri"/>
               </a:rPr>
-              <a:t>Proof of concept  |  Presentation to the Cabinet and the Chief Secretary</a:t>
+              <a:t>Proof of concept</a:t>
             </a:r>
           </a:p>
         </p:txBody>
@@ -8055,7 +8055,7 @@
                 </a:solidFill>
                 <a:latin typeface="Calibri"/>
               </a:rPr>
-              <a:t>District revenue after 2018 in the NITI workbooks is booked at the central treasury in Lucknow. We cross-checked against shop-level revenue and now point the system to the correct source.</a:t>
+              <a:t>District revenue after 2018 in the Rajkosh and Koshwani portal data is booked at the central treasury in Lucknow. We cross-checked against shop-level revenue and now point the system to the correct source.</a:t>
             </a:r>
           </a:p>
           <a:p>
@@ -8625,7 +8625,7 @@
                 </a:solidFill>
                 <a:latin typeface="Calibri"/>
               </a:rPr>
-              <a:t>Faster hardware</a:t>
+              <a:t>High-performance compute</a:t>
             </a:r>
           </a:p>
         </p:txBody>
@@ -8660,7 +8660,7 @@
                 </a:solidFill>
                 <a:latin typeface="Calibri"/>
               </a:rPr>
-              <a:t>A dedicated server with a graphics card brings answers down to seconds.</a:t>
+              <a:t>A high-performance computing (HPC) node with high-end GPU servers runs larger, more capable models and shortens response times.</a:t>
             </a:r>
           </a:p>
         </p:txBody>
@@ -9712,7 +9712,7 @@
                 </a:solidFill>
                 <a:latin typeface="Calibri"/>
               </a:rPr>
-              <a:t>2.  A dedicated server with a graphics card.</a:t>
+              <a:t>2.  A high-performance GPU compute node.</a:t>
             </a:r>
           </a:p>
           <a:p>
@@ -11393,8 +11393,8 @@
         </p:nvSpPr>
         <p:spPr>
           <a:xfrm>
-            <a:off x="548640" y="5440680"/>
-            <a:ext cx="11064240" cy="731520"/>
+            <a:off x="548640" y="5349240"/>
+            <a:ext cx="11064240" cy="914400"/>
           </a:xfrm>
           <a:prstGeom prst="rect">
             <a:avLst/>
@@ -11409,13 +11409,13 @@
           <a:p>
             <a:pPr algn="l"/>
             <a:r>
-              <a:rPr sz="2000" b="1">
+              <a:rPr sz="1900" b="1">
                 <a:solidFill>
                   <a:srgbClr val="243B7A"/>
                 </a:solidFill>
                 <a:latin typeface="Calibri"/>
               </a:rPr>
-              <a:t>It runs on a server in the department's own office. No question and no figure is sent to an outside AI service.</a:t>
+              <a:t>It runs on the departmental server, completely local. No external AI service provider and no closed-source or proprietary tool is used; all models run locally.</a:t>
             </a:r>
           </a:p>
         </p:txBody>
@@ -12959,7 +12959,7 @@
                 </a:solidFill>
                 <a:latin typeface="Calibri"/>
               </a:rPr>
-              <a:t>Source: the monthly dispatch report from the department's IESCMS system.</a:t>
+              <a:t>Source: the monthly dispatch report from the Integrated Excise Supply Chain Management System (IESCMS).</a:t>
             </a:r>
           </a:p>
         </p:txBody>
@@ -14396,13 +14396,13 @@
           <a:p>
             <a:pPr algn="l"/>
             <a:r>
-              <a:rPr sz="1600" b="0">
+              <a:rPr sz="1400" b="0">
                 <a:solidFill>
                   <a:srgbClr val="1F2937"/>
                 </a:solidFill>
                 <a:latin typeface="Calibri"/>
               </a:rPr>
-              <a:t>dispatch records, Lucknow, August 2026, from IESCMS</a:t>
+              <a:t>dispatch records for Lucknow, August 2026, from the Integrated Excise Supply Chain Management System</a:t>
             </a:r>
           </a:p>
         </p:txBody>
@@ -14582,7 +14582,7 @@
           <a:p>
             <a:pPr algn="l"/>
             <a:r>
-              <a:rPr sz="1600" b="0">
+              <a:rPr sz="1400" b="0">
                 <a:solidFill>
                   <a:srgbClr val="1F2937"/>
                 </a:solidFill>
@@ -14768,13 +14768,13 @@
           <a:p>
             <a:pPr algn="l"/>
             <a:r>
-              <a:rPr sz="1600" b="0">
+              <a:rPr sz="1400" b="0">
                 <a:solidFill>
                   <a:srgbClr val="1F2937"/>
                 </a:solidFill>
                 <a:latin typeface="Calibri"/>
               </a:rPr>
-              <a:t>district revenue records from the NITI workbooks</a:t>
+              <a:t>district revenue records from the Rajkosh and Koshwani portal data</a:t>
             </a:r>
           </a:p>
         </p:txBody>
@@ -14954,7 +14954,7 @@
           <a:p>
             <a:pPr algn="l"/>
             <a:r>
-              <a:rPr sz="1600" b="0">
+              <a:rPr sz="1400" b="0">
                 <a:solidFill>
                   <a:srgbClr val="1F2937"/>
                 </a:solidFill>
@@ -15140,7 +15140,7 @@
           <a:p>
             <a:pPr algn="l"/>
             <a:r>
-              <a:rPr sz="1600" b="0">
+              <a:rPr sz="1400" b="0">
                 <a:solidFill>
                   <a:srgbClr val="1F2937"/>
                 </a:solidFill>
@@ -15326,7 +15326,7 @@
           <a:p>
             <a:pPr algn="l"/>
             <a:r>
-              <a:rPr sz="1600" b="0">
+              <a:rPr sz="1400" b="0">
                 <a:solidFill>
                   <a:srgbClr val="1F2937"/>
                 </a:solidFill>

</xml_diff>

<commit_message>
Update the Cabinet demo deck wording
Same changes as dev: title slide, local-only statement, full portal names,
and the high-performance computing roadmap item.

Co-Authored-By: Claude Sonnet 5.5 <noreply@anthropic.com>
</commit_message>
<xml_diff>
--- a/deck/UP-Excise-Ask-the-Data-Demo.pptx
+++ b/deck/UP-Excise-Ask-the-Data-Demo.pptx
@@ -4837,7 +4837,7 @@
                 </a:solidFill>
                 <a:latin typeface="Calibri"/>
               </a:rPr>
-              <a:t>Proof of concept  |  Presentation to the Cabinet and the Chief Secretary</a:t>
+              <a:t>Proof of concept</a:t>
             </a:r>
           </a:p>
         </p:txBody>
@@ -8055,7 +8055,7 @@
                 </a:solidFill>
                 <a:latin typeface="Calibri"/>
               </a:rPr>
-              <a:t>District revenue after 2018 in the NITI workbooks is booked at the central treasury in Lucknow. We cross-checked against shop-level revenue and now point the system to the correct source.</a:t>
+              <a:t>District revenue after 2018 in the Rajkosh and Koshwani portal data is booked at the central treasury in Lucknow. We cross-checked against shop-level revenue and now point the system to the correct source.</a:t>
             </a:r>
           </a:p>
           <a:p>
@@ -8625,7 +8625,7 @@
                 </a:solidFill>
                 <a:latin typeface="Calibri"/>
               </a:rPr>
-              <a:t>Faster hardware</a:t>
+              <a:t>High-performance compute</a:t>
             </a:r>
           </a:p>
         </p:txBody>
@@ -8660,7 +8660,7 @@
                 </a:solidFill>
                 <a:latin typeface="Calibri"/>
               </a:rPr>
-              <a:t>A dedicated server with a graphics card brings answers down to seconds.</a:t>
+              <a:t>A high-performance computing (HPC) node with high-end GPU servers runs larger, more capable models and shortens response times.</a:t>
             </a:r>
           </a:p>
         </p:txBody>
@@ -9712,7 +9712,7 @@
                 </a:solidFill>
                 <a:latin typeface="Calibri"/>
               </a:rPr>
-              <a:t>2.  A dedicated server with a graphics card.</a:t>
+              <a:t>2.  A high-performance GPU compute node.</a:t>
             </a:r>
           </a:p>
           <a:p>
@@ -11393,8 +11393,8 @@
         </p:nvSpPr>
         <p:spPr>
           <a:xfrm>
-            <a:off x="548640" y="5440680"/>
-            <a:ext cx="11064240" cy="731520"/>
+            <a:off x="548640" y="5349240"/>
+            <a:ext cx="11064240" cy="914400"/>
           </a:xfrm>
           <a:prstGeom prst="rect">
             <a:avLst/>
@@ -11409,13 +11409,13 @@
           <a:p>
             <a:pPr algn="l"/>
             <a:r>
-              <a:rPr sz="2000" b="1">
+              <a:rPr sz="1900" b="1">
                 <a:solidFill>
                   <a:srgbClr val="243B7A"/>
                 </a:solidFill>
                 <a:latin typeface="Calibri"/>
               </a:rPr>
-              <a:t>It runs on a server in the department's own office. No question and no figure is sent to an outside AI service.</a:t>
+              <a:t>It runs on the departmental server, completely local. No external AI service provider and no closed-source or proprietary tool is used; all models run locally.</a:t>
             </a:r>
           </a:p>
         </p:txBody>
@@ -12959,7 +12959,7 @@
                 </a:solidFill>
                 <a:latin typeface="Calibri"/>
               </a:rPr>
-              <a:t>Source: the monthly dispatch report from the department's IESCMS system.</a:t>
+              <a:t>Source: the monthly dispatch report from the Integrated Excise Supply Chain Management System (IESCMS).</a:t>
             </a:r>
           </a:p>
         </p:txBody>
@@ -14396,13 +14396,13 @@
           <a:p>
             <a:pPr algn="l"/>
             <a:r>
-              <a:rPr sz="1600" b="0">
+              <a:rPr sz="1400" b="0">
                 <a:solidFill>
                   <a:srgbClr val="1F2937"/>
                 </a:solidFill>
                 <a:latin typeface="Calibri"/>
               </a:rPr>
-              <a:t>dispatch records, Lucknow, August 2026, from IESCMS</a:t>
+              <a:t>dispatch records for Lucknow, August 2026, from the Integrated Excise Supply Chain Management System</a:t>
             </a:r>
           </a:p>
         </p:txBody>
@@ -14582,7 +14582,7 @@
           <a:p>
             <a:pPr algn="l"/>
             <a:r>
-              <a:rPr sz="1600" b="0">
+              <a:rPr sz="1400" b="0">
                 <a:solidFill>
                   <a:srgbClr val="1F2937"/>
                 </a:solidFill>
@@ -14768,13 +14768,13 @@
           <a:p>
             <a:pPr algn="l"/>
             <a:r>
-              <a:rPr sz="1600" b="0">
+              <a:rPr sz="1400" b="0">
                 <a:solidFill>
                   <a:srgbClr val="1F2937"/>
                 </a:solidFill>
                 <a:latin typeface="Calibri"/>
               </a:rPr>
-              <a:t>district revenue records from the NITI workbooks</a:t>
+              <a:t>district revenue records from the Rajkosh and Koshwani portal data</a:t>
             </a:r>
           </a:p>
         </p:txBody>
@@ -14954,7 +14954,7 @@
           <a:p>
             <a:pPr algn="l"/>
             <a:r>
-              <a:rPr sz="1600" b="0">
+              <a:rPr sz="1400" b="0">
                 <a:solidFill>
                   <a:srgbClr val="1F2937"/>
                 </a:solidFill>
@@ -15140,7 +15140,7 @@
           <a:p>
             <a:pPr algn="l"/>
             <a:r>
-              <a:rPr sz="1600" b="0">
+              <a:rPr sz="1400" b="0">
                 <a:solidFill>
                   <a:srgbClr val="1F2937"/>
                 </a:solidFill>
@@ -15326,7 +15326,7 @@
           <a:p>
             <a:pPr algn="l"/>
             <a:r>
-              <a:rPr sz="1600" b="0">
+              <a:rPr sz="1400" b="0">
                 <a:solidFill>
                   <a:srgbClr val="1F2937"/>
                 </a:solidFill>

</xml_diff>

<commit_message>
Address the decision slide to the respected authorities
Slide 15 asks the respected authorities for a decision, and the monthly data
feeds step names the involved stakeholders. The speaker notes and
SLIDE-TRANSCRIPT.md no longer refer to the Cabinet.

Co-Authored-By: Claude Sonnet 5.5 <noreply@anthropic.com>
</commit_message>
<xml_diff>
--- a/deck/UP-Excise-Ask-the-Data-Demo.pptx
+++ b/deck/UP-Excise-Ask-the-Data-Demo.pptx
@@ -796,7 +796,7 @@
           <a:lstStyle/>
           <a:p>
             <a:r>
-              <a:t>Being open about limits is deliberate. The cabinet will ask what can go wrong; this slide answers before they do.</a:t>
+              <a:t>Being open about limits is deliberate. The audience will ask what can go wrong; this slide answers before they do.</a:t>
             </a:r>
           </a:p>
         </p:txBody>
@@ -9622,7 +9622,7 @@
                 </a:solidFill>
                 <a:latin typeface="Calibri"/>
               </a:rPr>
-              <a:t>We ask the Cabinet and the Chief Secretary for a decision on the next step.</a:t>
+              <a:t>We ask the respected authorities for a decision on the next step.</a:t>
             </a:r>
           </a:p>
         </p:txBody>
@@ -9728,7 +9728,7 @@
                 </a:solidFill>
                 <a:latin typeface="Calibri"/>
               </a:rPr>
-              <a:t>3.  Monthly data feeds from the source systems.</a:t>
+              <a:t>3.  Monthly data feeds from the source systems and involved stakeholders.</a:t>
             </a:r>
           </a:p>
         </p:txBody>

</xml_diff>

<commit_message>
Revise the deck wording and drop the tunnel line from the safety slide
Split long bullets, plain statements in place of the slide 9 slogan bar,
a two-sentence title tagline, and 'we' in the speaker notes. The safety
slide no longer names the Cloudflare tunnel: it is a stop-gap for this
server and not part of the design.

Co-Authored-By: Claude Sonnet 5.5 <noreply@anthropic.com>
</commit_message>
<xml_diff>
--- a/deck/UP-Excise-Ask-the-Data-Demo.pptx
+++ b/deck/UP-Excise-Ask-the-Data-Demo.pptx
@@ -516,7 +516,7 @@
           <a:lstStyle/>
           <a:p>
             <a:r>
-              <a:t>Welcome. This is a working proof of concept, not a mock-up. Everything shown in the demo slides came from the live system running in the department's office, answering real questions against real department data.</a:t>
+              <a:t>Welcome. This is a working proof of concept, not a mock-up. Everything in the demo slides came from the live system running in the department's office. It answered real questions against real department data.</a:t>
             </a:r>
           </a:p>
         </p:txBody>
@@ -726,7 +726,7 @@
           <a:lstStyle/>
           <a:p>
             <a:r>
-              <a:t>Mention that the build followed a written plan with milestones, and that every live failure found in testing is documented. Honest testing is part of the case for trusting the results.</a:t>
+              <a:t>We followed a written plan with milestones, and every live failure found in testing is documented. Honest testing is part of the case for trusting the results.</a:t>
             </a:r>
           </a:p>
         </p:txBody>
@@ -796,7 +796,7 @@
           <a:lstStyle/>
           <a:p>
             <a:r>
-              <a:t>Being open about limits is deliberate. The audience will ask what can go wrong; this slide answers before they do.</a:t>
+              <a:t>We are open about limits deliberately. The audience will ask what can go wrong; this slide answers first.</a:t>
             </a:r>
           </a:p>
         </p:txBody>
@@ -1006,7 +1006,7 @@
           <a:lstStyle/>
           <a:p>
             <a:r>
-              <a:t>Set the scene in the department's own terms. Examples to mention: a district total needed before a review meeting; a rule position needed alongside a figure.</a:t>
+              <a:t>Set the scene in the department's own terms. Two examples to mention: a district total needed before a review meeting, and a rule position needed alongside a figure.</a:t>
             </a:r>
           </a:p>
         </p:txBody>
@@ -1076,7 +1076,7 @@
           <a:lstStyle/>
           <a:p>
             <a:r>
-              <a:t>Three entry points, one engine. Ask is for a single well-formed question. Chat is for exploring. The knowledge library lets the same chat quote the department's published rules.</a:t>
+              <a:t>We built three entry points on one engine. Ask takes a single well-formed question. Chat is for exploring. The knowledge library lets the same chat quote the department's published rules.</a:t>
             </a:r>
           </a:p>
         </p:txBody>
@@ -1216,7 +1216,7 @@
           <a:lstStyle/>
           <a:p>
             <a:r>
-              <a:t>Click the screenshot to open it full size. Read the question aloud, then point to the total and the two parts. This question was chosen because it has a split and a total. Earlier versions gave only one combined number; we fixed that so each part is shown.</a:t>
+              <a:t>Click the screenshot to open it full size. Read the question aloud, then point to the total and the two parts. This question was chosen because it has a split and a total. Earlier versions gave one combined number; we fixed that so each part is shown.</a:t>
             </a:r>
           </a:p>
         </p:txBody>
@@ -1426,7 +1426,7 @@
           <a:lstStyle/>
           <a:p>
             <a:r>
-              <a:t>These are the row counts loaded so far. The data bank is a copy; the source systems are untouched. More sources can be added without changing how officers ask questions.</a:t>
+              <a:t>These are the row counts loaded so far. The data bank is a copy; the source systems are untouched. We can add more sources without changing how officers ask questions.</a:t>
             </a:r>
           </a:p>
         </p:txBody>
@@ -1496,7 +1496,7 @@
           <a:lstStyle/>
           <a:p>
             <a:r>
-              <a:t>Both models are open weights, run through Ollama on the office server. Neither is a DeepSeek model. The server has no GPU today, which is why answers take one to three minutes.</a:t>
+              <a:t>Both models are open weights, run through Ollama on the office server. Neither is a DeepSeek model. The server has no graphics card today, so answers take one to three minutes.</a:t>
             </a:r>
           </a:p>
         </p:txBody>
@@ -4781,7 +4781,7 @@
         <p:spPr>
           <a:xfrm>
             <a:off x="731520" y="3794760"/>
-            <a:ext cx="7498079" cy="1280160"/>
+            <a:ext cx="8229600" cy="1463040"/>
           </a:xfrm>
           <a:prstGeom prst="rect">
             <a:avLst/>
@@ -4794,7 +4794,11 @@
           </a:bodyPr>
           <a:lstStyle/>
           <a:p>
-            <a:pPr algn="l"/>
+            <a:pPr algn="l">
+              <a:spcAft>
+                <a:spcPts val="600"/>
+              </a:spcAft>
+            </a:pPr>
             <a:r>
               <a:rPr sz="2400" b="0">
                 <a:solidFill>
@@ -4802,7 +4806,23 @@
                 </a:solidFill>
                 <a:latin typeface="Calibri"/>
               </a:rPr>
-              <a:t>Questions in plain language, answered from the department's own figures and rules, on the department's own server</a:t>
+              <a:t>Ask a question in plain language.</a:t>
+            </a:r>
+          </a:p>
+          <a:p>
+            <a:pPr algn="l">
+              <a:spcAft>
+                <a:spcPts val="600"/>
+              </a:spcAft>
+            </a:pPr>
+            <a:r>
+              <a:rPr sz="2400" b="0">
+                <a:solidFill>
+                  <a:srgbClr val="1F2937"/>
+                </a:solidFill>
+                <a:latin typeface="Calibri"/>
+              </a:rPr>
+              <a:t>The answer comes from the department's own figures and rules, on the department's own server.</a:t>
             </a:r>
           </a:p>
         </p:txBody>
@@ -6005,41 +6025,6 @@
           </a:p>
         </p:txBody>
       </p:sp>
-      <p:sp>
-        <p:nvSpPr>
-          <p:cNvPr id="33" name="TextBox 32"/>
-          <p:cNvSpPr txBox="1"/>
-          <p:nvPr/>
-        </p:nvSpPr>
-        <p:spPr>
-          <a:xfrm>
-            <a:off x="548640" y="6144768"/>
-            <a:ext cx="11064240" cy="274320"/>
-          </a:xfrm>
-          <a:prstGeom prst="rect">
-            <a:avLst/>
-          </a:prstGeom>
-          <a:noFill/>
-        </p:spPr>
-        <p:txBody>
-          <a:bodyPr wrap="square" anchor="t" lIns="45720" rIns="45720" tIns="27432" bIns="27432">
-            <a:spAutoFit/>
-          </a:bodyPr>
-          <a:lstStyle/>
-          <a:p>
-            <a:pPr algn="l"/>
-            <a:r>
-              <a:rPr sz="1300" b="0">
-                <a:solidFill>
-                  <a:srgbClr val="4B5563"/>
-                </a:solidFill>
-                <a:latin typeface="Calibri"/>
-              </a:rPr>
-              <a:t>The only outside connection is the secure tunnel that lets officers reach the site.</a:t>
-            </a:r>
-          </a:p>
-        </p:txBody>
-      </p:sp>
     </p:spTree>
   </p:cSld>
   <p:clrMapOvr>
@@ -7676,7 +7661,11 @@
           </a:bodyPr>
           <a:lstStyle/>
           <a:p>
-            <a:pPr algn="l"/>
+            <a:pPr algn="l">
+              <a:spcAft>
+                <a:spcPts val="400"/>
+              </a:spcAft>
+            </a:pPr>
             <a:r>
               <a:rPr sz="1700" b="0">
                 <a:solidFill>
@@ -7684,7 +7673,23 @@
                 </a:solidFill>
                 <a:latin typeface="Calibri"/>
               </a:rPr>
-              <a:t>The automated tests cover the safety checks, the data loaders and the chat flow. Live testing against real questions found problems the tests could not, and each one was fixed and recorded.</a:t>
+              <a:t>The automated tests cover the safety checks, the data loaders and the chat flow.</a:t>
+            </a:r>
+          </a:p>
+          <a:p>
+            <a:pPr algn="l">
+              <a:spcAft>
+                <a:spcPts val="400"/>
+              </a:spcAft>
+            </a:pPr>
+            <a:r>
+              <a:rPr sz="1700" b="0">
+                <a:solidFill>
+                  <a:srgbClr val="1F2937"/>
+                </a:solidFill>
+                <a:latin typeface="Calibri"/>
+              </a:rPr>
+              <a:t>Live testing on real questions found problems the tests could not. Each one was fixed and recorded.</a:t>
             </a:r>
           </a:p>
         </p:txBody>
@@ -8055,7 +8060,23 @@
                 </a:solidFill>
                 <a:latin typeface="Calibri"/>
               </a:rPr>
-              <a:t>District revenue after 2018 in the Rajkosh and Koshwani portal data is booked at the central treasury in Lucknow. We cross-checked against shop-level revenue and now point the system to the correct source.</a:t>
+              <a:t>District revenue after 2018 in the Rajkosh and Koshwani portal data is booked at the central treasury in Lucknow.</a:t>
+            </a:r>
+          </a:p>
+          <a:p>
+            <a:pPr algn="l">
+              <a:spcAft>
+                <a:spcPts val="1000"/>
+              </a:spcAft>
+            </a:pPr>
+            <a:r>
+              <a:rPr sz="1500" b="0">
+                <a:solidFill>
+                  <a:srgbClr val="1F2937"/>
+                </a:solidFill>
+                <a:latin typeface="Calibri"/>
+              </a:rPr>
+              <a:t>We cross-checked against shop-level revenue and now point the system to the correct source.</a:t>
             </a:r>
           </a:p>
           <a:p>
@@ -10333,7 +10354,7 @@
                 </a:solidFill>
                 <a:latin typeface="Calibri"/>
               </a:rPr>
-              <a:t>An officer asks, an analyst finds the files, builds the table and sends it back. A new angle on the same question starts the cycle again.</a:t>
+              <a:t>An officer asks, an analyst finds the files, builds the table and sends it back. A new angle starts the cycle again.</a:t>
             </a:r>
           </a:p>
         </p:txBody>
@@ -10554,7 +10575,7 @@
                 </a:solidFill>
                 <a:latin typeface="Calibri"/>
               </a:rPr>
-              <a:t>An officer who needs a number for a meeting today should be able to get it today, with the source shown, without waiting for a report to be prepared.</a:t>
+              <a:t>An officer who needs a number for a meeting today should get it today, with its source, without waiting for a report.</a:t>
             </a:r>
           </a:p>
         </p:txBody>
@@ -11407,7 +11428,11 @@
           </a:bodyPr>
           <a:lstStyle/>
           <a:p>
-            <a:pPr algn="l"/>
+            <a:pPr algn="l">
+              <a:spcAft>
+                <a:spcPts val="400"/>
+              </a:spcAft>
+            </a:pPr>
             <a:r>
               <a:rPr sz="1900" b="1">
                 <a:solidFill>
@@ -11415,7 +11440,23 @@
                 </a:solidFill>
                 <a:latin typeface="Calibri"/>
               </a:rPr>
-              <a:t>It runs on the departmental server, completely local. No external AI service provider and no closed-source or proprietary tool is used; all models run locally.</a:t>
+              <a:t>It runs on the departmental server, completely local.</a:t>
+            </a:r>
+          </a:p>
+          <a:p>
+            <a:pPr algn="l">
+              <a:spcAft>
+                <a:spcPts val="400"/>
+              </a:spcAft>
+            </a:pPr>
+            <a:r>
+              <a:rPr sz="1900" b="1">
+                <a:solidFill>
+                  <a:srgbClr val="243B7A"/>
+                </a:solidFill>
+                <a:latin typeface="Calibri"/>
+              </a:rPr>
+              <a:t>No external AI service provider and no closed-source or proprietary tool is used. All models run locally.</a:t>
             </a:r>
           </a:p>
         </p:txBody>
@@ -12943,7 +12984,7 @@
                 </a:solidFill>
                 <a:latin typeface="Calibri"/>
               </a:rPr>
-              <a:t>The total is counted by the database itself, not added up by the AI.</a:t>
+              <a:t>The database counts the total; the AI does not add it up.</a:t>
             </a:r>
           </a:p>
           <a:p>
@@ -16164,7 +16205,7 @@
                 </a:solidFill>
                 <a:latin typeface="Calibri"/>
               </a:rPr>
-              <a:t>Why two models: a conversational model and a code-writing model are each better at their own task.</a:t>
+              <a:t>A conversational model and a code-writing model each do their own job better, so we use two.</a:t>
             </a:r>
           </a:p>
           <a:p>
@@ -16180,7 +16221,7 @@
                 </a:solidFill>
                 <a:latin typeface="Calibri"/>
               </a:rPr>
-              <a:t>Why local: the department's questions and figures never leave the building.</a:t>
+              <a:t>Both run locally: the department's questions and figures never leave the building.</a:t>
             </a:r>
           </a:p>
         </p:txBody>

</xml_diff>

<commit_message>
Give every deck slide a title
The slides sat on the Blank layout with a plain text box for the heading, so
PowerPoint's outline and the PDF bookmarks listed 'Slide 1', 'Slide 2'. Each
heading is now the slide's title placeholder, in both decks and in the builder.

Co-Authored-By: Claude Sonnet 5.5 <noreply@anthropic.com>
</commit_message>
<xml_diff>
--- a/deck/UP-Excise-Ask-the-Data-Demo.pptx
+++ b/deck/UP-Excise-Ask-the-Data-Demo.pptx
@@ -4521,9 +4521,11 @@
       </p:sp>
       <p:sp>
         <p:nvSpPr>
-          <p:cNvPr id="8" name="TextBox 7"/>
-          <p:cNvSpPr txBox="1"/>
-          <p:nvPr/>
+          <p:cNvPr id="8" name="Title"/>
+          <p:cNvSpPr/>
+          <p:nvPr>
+            <p:ph type="ctrTitle"/>
+          </p:nvPr>
         </p:nvSpPr>
         <p:spPr>
           <a:xfrm>
@@ -4759,9 +4761,11 @@
       </p:sp>
       <p:sp>
         <p:nvSpPr>
-          <p:cNvPr id="4" name="TextBox 3"/>
-          <p:cNvSpPr txBox="1"/>
-          <p:nvPr/>
+          <p:cNvPr id="4" name="Title"/>
+          <p:cNvSpPr/>
+          <p:nvPr>
+            <p:ph type="title"/>
+          </p:nvPr>
         </p:nvSpPr>
         <p:spPr>
           <a:xfrm>
@@ -5941,9 +5945,11 @@
       </p:sp>
       <p:sp>
         <p:nvSpPr>
-          <p:cNvPr id="4" name="TextBox 3"/>
-          <p:cNvSpPr txBox="1"/>
-          <p:nvPr/>
+          <p:cNvPr id="4" name="Title"/>
+          <p:cNvSpPr/>
+          <p:nvPr>
+            <p:ph type="title"/>
+          </p:nvPr>
         </p:nvSpPr>
         <p:spPr>
           <a:xfrm>
@@ -6403,9 +6409,11 @@
       </p:sp>
       <p:sp>
         <p:nvSpPr>
-          <p:cNvPr id="4" name="TextBox 3"/>
-          <p:cNvSpPr txBox="1"/>
-          <p:nvPr/>
+          <p:cNvPr id="4" name="Title"/>
+          <p:cNvSpPr/>
+          <p:nvPr>
+            <p:ph type="title"/>
+          </p:nvPr>
         </p:nvSpPr>
         <p:spPr>
           <a:xfrm>
@@ -7640,9 +7648,11 @@
       </p:sp>
       <p:sp>
         <p:nvSpPr>
-          <p:cNvPr id="4" name="TextBox 3"/>
-          <p:cNvSpPr txBox="1"/>
-          <p:nvPr/>
+          <p:cNvPr id="4" name="Title"/>
+          <p:cNvSpPr/>
+          <p:nvPr>
+            <p:ph type="title"/>
+          </p:nvPr>
         </p:nvSpPr>
         <p:spPr>
           <a:xfrm>
@@ -8224,9 +8234,11 @@
       </p:sp>
       <p:sp>
         <p:nvSpPr>
-          <p:cNvPr id="4" name="TextBox 3"/>
-          <p:cNvSpPr txBox="1"/>
-          <p:nvPr/>
+          <p:cNvPr id="4" name="Title"/>
+          <p:cNvSpPr/>
+          <p:nvPr>
+            <p:ph type="title"/>
+          </p:nvPr>
         </p:nvSpPr>
         <p:spPr>
           <a:xfrm>
@@ -9218,9 +9230,11 @@
       </p:sp>
       <p:sp>
         <p:nvSpPr>
-          <p:cNvPr id="4" name="TextBox 3"/>
-          <p:cNvSpPr txBox="1"/>
-          <p:nvPr/>
+          <p:cNvPr id="4" name="Title"/>
+          <p:cNvSpPr/>
+          <p:nvPr>
+            <p:ph type="title"/>
+          </p:nvPr>
         </p:nvSpPr>
         <p:spPr>
           <a:xfrm>
@@ -9739,9 +9753,11 @@
       </p:sp>
       <p:sp>
         <p:nvSpPr>
-          <p:cNvPr id="4" name="TextBox 3"/>
-          <p:cNvSpPr txBox="1"/>
-          <p:nvPr/>
+          <p:cNvPr id="4" name="Title"/>
+          <p:cNvSpPr/>
+          <p:nvPr>
+            <p:ph type="title"/>
+          </p:nvPr>
         </p:nvSpPr>
         <p:spPr>
           <a:xfrm>
@@ -10580,9 +10596,11 @@
       </p:sp>
       <p:sp>
         <p:nvSpPr>
-          <p:cNvPr id="4" name="TextBox 3"/>
-          <p:cNvSpPr txBox="1"/>
-          <p:nvPr/>
+          <p:cNvPr id="4" name="Title"/>
+          <p:cNvSpPr/>
+          <p:nvPr>
+            <p:ph type="title"/>
+          </p:nvPr>
         </p:nvSpPr>
         <p:spPr>
           <a:xfrm>
@@ -11476,9 +11494,11 @@
       </p:sp>
       <p:sp>
         <p:nvSpPr>
-          <p:cNvPr id="4" name="TextBox 3"/>
-          <p:cNvSpPr txBox="1"/>
-          <p:nvPr/>
+          <p:cNvPr id="4" name="Title"/>
+          <p:cNvSpPr/>
+          <p:nvPr>
+            <p:ph type="title"/>
+          </p:nvPr>
         </p:nvSpPr>
         <p:spPr>
           <a:xfrm>
@@ -12686,9 +12706,11 @@
       </p:sp>
       <p:sp>
         <p:nvSpPr>
-          <p:cNvPr id="4" name="TextBox 3"/>
-          <p:cNvSpPr txBox="1"/>
-          <p:nvPr/>
+          <p:cNvPr id="4" name="Title"/>
+          <p:cNvSpPr/>
+          <p:nvPr>
+            <p:ph type="title"/>
+          </p:nvPr>
         </p:nvSpPr>
         <p:spPr>
           <a:xfrm>
@@ -13125,9 +13147,11 @@
       </p:sp>
       <p:sp>
         <p:nvSpPr>
-          <p:cNvPr id="4" name="TextBox 3"/>
-          <p:cNvSpPr txBox="1"/>
-          <p:nvPr/>
+          <p:cNvPr id="4" name="Title"/>
+          <p:cNvSpPr/>
+          <p:nvPr>
+            <p:ph type="title"/>
+          </p:nvPr>
         </p:nvSpPr>
         <p:spPr>
           <a:xfrm>
@@ -13657,9 +13681,11 @@
       </p:sp>
       <p:sp>
         <p:nvSpPr>
-          <p:cNvPr id="4" name="TextBox 3"/>
-          <p:cNvSpPr txBox="1"/>
-          <p:nvPr/>
+          <p:cNvPr id="4" name="Title"/>
+          <p:cNvSpPr/>
+          <p:nvPr>
+            <p:ph type="title"/>
+          </p:nvPr>
         </p:nvSpPr>
         <p:spPr>
           <a:xfrm>
@@ -14096,9 +14122,11 @@
       </p:sp>
       <p:sp>
         <p:nvSpPr>
-          <p:cNvPr id="4" name="TextBox 3"/>
-          <p:cNvSpPr txBox="1"/>
-          <p:nvPr/>
+          <p:cNvPr id="4" name="Title"/>
+          <p:cNvSpPr/>
+          <p:nvPr>
+            <p:ph type="title"/>
+          </p:nvPr>
         </p:nvSpPr>
         <p:spPr>
           <a:xfrm>
@@ -15561,9 +15589,11 @@
       </p:sp>
       <p:sp>
         <p:nvSpPr>
-          <p:cNvPr id="4" name="TextBox 3"/>
-          <p:cNvSpPr txBox="1"/>
-          <p:nvPr/>
+          <p:cNvPr id="4" name="Title"/>
+          <p:cNvSpPr/>
+          <p:nvPr>
+            <p:ph type="title"/>
+          </p:nvPr>
         </p:nvSpPr>
         <p:spPr>
           <a:xfrm>

</xml_diff>